<commit_message>
Son denetim: kalite raporu final set üzerinde, Türkçe sayı biçimi ve sunum düzeltmesi
- Kalite kontrol raporunun otomatik kontrolleri artık elle incelemeden sonraki final seti sayıyor
  (3.388 örnek, 451/451 çoktan seçmeli); elenme tablosunda qc_fail ve toplam 574 satırı
- Kart: "Adim" düzeltmesinden biri sonradan elendiği için final sette 19 olduğu belirtildi
- Ortalama doküman uzunluğu 997'ye yuvarlandı; ondalıklar Türkçe biçimde (996,8; 0,85)
- Sunum 13. slayt: 12 sorunun 6'sı yalnız alt konu etiketi
- Veri dosyaları değişmedi
</commit_message>
<xml_diff>
--- a/reports/AstroTutor_AI_Vize_Sunumu.pptx
+++ b/reports/AstroTutor_AI_Vize_Sunumu.pptx
@@ -122,14 +122,14 @@
   <p:extLst>
     <p:ext uri="{521415D9-36F7-43E2-AB2F-B90AF26B5E84}">
       <p14:sectionLst xmlns:p14="http://schemas.microsoft.com/office/powerpoint/2010/main">
-        <p14:section name="Giriş" id="{ccbb5dda-86d8-e602-d930-308adca81a25}">
+        <p14:section name="Giriş" id="{81e9e877-dc37-19bf-efe4-c7bb0fa6970c}">
           <p14:sldIdLst>
             <p14:sldId id="256"/>
             <p14:sldId id="257"/>
             <p14:sldId id="258"/>
           </p14:sldIdLst>
         </p14:section>
-        <p14:section name="Domain Corpus" id="{cceace94-3c25-b00e-4b4e-55ef007ff993}">
+        <p14:section name="Domain Corpus" id="{67798edf-9f8c-fee8-2942-92900d7d3392}">
           <p14:sldIdLst>
             <p14:sldId id="259"/>
             <p14:sldId id="260"/>
@@ -139,14 +139,14 @@
             <p14:sldId id="264"/>
           </p14:sldIdLst>
         </p14:section>
-        <p14:section name="Instruction Dataset" id="{86fbdb5a-96df-208a-34bd-d6c5138d777a}">
+        <p14:section name="Instruction Dataset" id="{48c7b8fe-723b-dcd4-c413-9b6e01ae2197}">
           <p14:sldIdLst>
             <p14:sldId id="265"/>
             <p14:sldId id="266"/>
             <p14:sldId id="267"/>
           </p14:sldIdLst>
         </p14:section>
-        <p14:section name="Kalite ve plan" id="{7c83a816-809c-ac73-cef6-2204a2da5c4b}">
+        <p14:section name="Kalite ve plan" id="{acc64f97-51f1-3a80-01de-578b132fbc56}">
           <p14:sldIdLst>
             <p14:sldId id="268"/>
             <p14:sldId id="269"/>
@@ -3270,7 +3270,7 @@
           <a:p>
             <a:r>
               <a:rPr lang="en-US" dirty="0"/>
-              <a:t>Corpus 16,2 milyon token; ortalama doküman 996, medyan 391 token. Alt konular dengeli: tek bir konu baskın değil. Türkçe pay %16,9. Ayrım doküman (grup) düzeyinde %90/5/5, seed 42; aynı Wikipedia maddesinin EN/TR sürümleri aynı kümede; chunk'lar bölmeden sonra üretildi. Neden 300 karakter alt sınırı: 300–500 aralığındaki 283 dokümanın 110'u değerli Türkçe madde; 500 seçseydik kaybolurdu.</a:t>
+              <a:t>Corpus 16,2 milyon token; ortalama doküman 997, medyan 391 token. Alt konular dengeli: tek bir konu baskın değil. Türkçe pay %16,9. Ayrım doküman (grup) düzeyinde %90/5/5, seed 42; aynı Wikipedia maddesinin EN/TR sürümleri aynı kümede; chunk'lar bölmeden sonra üretildi. Neden 300 karakter alt sınırı: 300–500 aralığındaki 283 dokümanın 110'u değerli Türkçe madde; 500 seçseydik kaybolurdu.</a:t>
             </a:r>
             <a:endParaRPr lang="en-US" dirty="0"/>
           </a:p>
@@ -6410,7 +6410,7 @@
                   <a:schemeClr val="tx2"/>
                 </a:solidFill>
               </a:rPr>
-              <a:t>sorunların 7'si yalnız alt konu etiketi · metinde sorun %6</a:t>
+              <a:t>12 sorunun 6'sı yalnız alt konu etiketi · metinde sorun %6</a:t>
             </a:r>
             <a:endParaRPr lang="en-US" sz="1400" dirty="0"/>
           </a:p>

</xml_diff>

<commit_message>
Corpus v1.0 düzeltmesi: cümle sonundaki 5 basın telefonu maskelendi
- press_boilerplate: telefon kuralı numaradan sonra gelen cümle noktasını kabul ediyor; ondalık sayılar
  ve tutarsız ayraçlı sayı dizileri telefon sayılmıyor (testli)
- Corpus 06 → 06b → 06b → 07 ile yeniden üretildi: yalnız 5 dokümanın metni değişti, doküman sayısı,
  kimlikler, kümeler ve chunk sayısı aynı (token −53)
- Kart, istatistik, sunum (6. ve 15. slayt), taslak ve karar günlüğü güncellendi; veri paketi SHA-256'sı yenilendi
</commit_message>
<xml_diff>
--- a/reports/AstroTutor_AI_Vize_Sunumu.pptx
+++ b/reports/AstroTutor_AI_Vize_Sunumu.pptx
@@ -122,14 +122,14 @@
   <p:extLst>
     <p:ext uri="{521415D9-36F7-43E2-AB2F-B90AF26B5E84}">
       <p14:sectionLst xmlns:p14="http://schemas.microsoft.com/office/powerpoint/2010/main">
-        <p14:section name="Giriş" id="{81e9e877-dc37-19bf-efe4-c7bb0fa6970c}">
+        <p14:section name="Giriş" id="{bedf7f1c-f127-40d7-36f2-975d7db01ec1}">
           <p14:sldIdLst>
             <p14:sldId id="256"/>
             <p14:sldId id="257"/>
             <p14:sldId id="258"/>
           </p14:sldIdLst>
         </p14:section>
-        <p14:section name="Domain Corpus" id="{67798edf-9f8c-fee8-2942-92900d7d3392}">
+        <p14:section name="Domain Corpus" id="{895e8896-34ec-820f-76e1-b59ea88d2eff}">
           <p14:sldIdLst>
             <p14:sldId id="259"/>
             <p14:sldId id="260"/>
@@ -139,14 +139,14 @@
             <p14:sldId id="264"/>
           </p14:sldIdLst>
         </p14:section>
-        <p14:section name="Instruction Dataset" id="{48c7b8fe-723b-dcd4-c413-9b6e01ae2197}">
+        <p14:section name="Instruction Dataset" id="{30321691-e338-3273-22ae-bc0beae294f9}">
           <p14:sldIdLst>
             <p14:sldId id="265"/>
             <p14:sldId id="266"/>
             <p14:sldId id="267"/>
           </p14:sldIdLst>
         </p14:section>
-        <p14:section name="Kalite ve plan" id="{acc64f97-51f1-3a80-01de-578b132fbc56}">
+        <p14:section name="Kalite ve plan" id="{cb729245-ee4b-125b-3a63-975c42a656e4}">
           <p14:sldIdLst>
             <p14:sldId id="268"/>
             <p14:sldId id="269"/>
@@ -2478,7 +2478,7 @@
           <a:p>
             <a:r>
               <a:rPr lang="en-US" dirty="0"/>
-              <a:t>Önce Instruction v1.1: yargıcı örneklem dışındaki bütün lite üretimlerine genişletiyoruz (kod hazır ve test edildi, --extended). Sonra CPT: corpus 16,2 M token ve çoğunlukla İngilizce olduğu için düşük öğrenme hızı ve genel Türkçe metinle karıştırma. Ardından SFT ve üç sistemin karşılaştırılması. Son olarak RAG: güncel sayısal bilgiler (ör. ötegezegen sayısı) model ağırlıklarına değil RAG katmanına.</a:t>
+              <a:t>Önce Instruction v1.1: yargıcı örneklem dışındaki bütün lite üretimlerine genişletiyoruz (--extended; 26.10'da başladı, 30.10 itibarıyla 290 işin 113'ü değerlendirildi: 875 örnekten 95'i başarısız, %10,9; örneklemdeki lite oranına yakın). Sonra CPT: corpus 16,2 M token ve çoğunlukla İngilizce olduğu için düşük öğrenme hızı ve genel Türkçe metinle karıştırma. Ardından SFT ve üç sistemin karşılaştırılması. Son olarak RAG: güncel sayısal bilgiler (ör. ötegezegen sayısı) model ağırlıklarına değil RAG katmanına.</a:t>
             </a:r>
             <a:endParaRPr lang="en-US" dirty="0"/>
           </a:p>
@@ -8779,7 +8779,7 @@
                   <a:schemeClr val="tx1"/>
                 </a:solidFill>
               </a:rPr>
-              <a:t>Yargıcı tüm lite üretimlerine genişletme (kod hazır)</a:t>
+              <a:t>Yargıcı tüm lite üretimlerine genişletme (başladı)</a:t>
             </a:r>
             <a:endParaRPr lang="en-US" sz="1500" dirty="0"/>
           </a:p>
@@ -17424,7 +17424,7 @@
                   <a:schemeClr val="tx1"/>
                 </a:solidFill>
               </a:rPr>
-              <a:t>Künye silindi · 348 e-posta, 183 telefon → 0</a:t>
+              <a:t>Künye silindi · 348 e-posta, 188 telefon → 0</a:t>
             </a:r>
             <a:endParaRPr lang="en-US" sz="1500" dirty="0"/>
           </a:p>

</xml_diff>